<commit_message>
Sprint 2: complete task extraction, human evaluation setup and O*NET alignment
</commit_message>
<xml_diff>
--- a/outputs/presentation/Workhuman_Taxonomy_Meeting_Progress.pptx
+++ b/outputs/presentation/Workhuman_Taxonomy_Meeting_Progress.pptx
@@ -5,16 +5,16 @@
     <p:sldMasterId id="2147483648" r:id="rId1"/>
   </p:sldMasterIdLst>
   <p:sldIdLst>
-    <p:sldId id="256" r:id="rId7"/>
-    <p:sldId id="257" r:id="rId8"/>
-    <p:sldId id="258" r:id="rId9"/>
-    <p:sldId id="259" r:id="rId10"/>
-    <p:sldId id="260" r:id="rId11"/>
-    <p:sldId id="261" r:id="rId12"/>
-    <p:sldId id="262" r:id="rId13"/>
-    <p:sldId id="263" r:id="rId14"/>
+    <p:sldId id="256" r:id="rId2"/>
+    <p:sldId id="257" r:id="rId3"/>
+    <p:sldId id="258" r:id="rId4"/>
+    <p:sldId id="259" r:id="rId5"/>
+    <p:sldId id="260" r:id="rId6"/>
+    <p:sldId id="261" r:id="rId7"/>
+    <p:sldId id="262" r:id="rId8"/>
+    <p:sldId id="263" r:id="rId9"/>
   </p:sldIdLst>
-  <p:sldSz cx="12191695" cy="6858000" type="screen4x3"/>
+  <p:sldSz cx="12192000" cy="6858000"/>
   <p:notesSz cx="6858000" cy="9144000"/>
   <p:defaultTextStyle>
     <a:defPPr>
@@ -111,6 +111,22 @@
       </a:defRPr>
     </a:lvl9pPr>
   </p:defaultTextStyle>
+  <p:extLst>
+    <p:ext uri="{EFAFB233-063F-42B5-8137-9DF3F51BA10A}">
+      <p15:sldGuideLst xmlns:p15="http://schemas.microsoft.com/office/powerpoint/2012/main">
+        <p15:guide id="1" orient="horz" pos="2160">
+          <p15:clr>
+            <a:srgbClr val="A4A3A4"/>
+          </p15:clr>
+        </p15:guide>
+        <p15:guide id="2" pos="2880">
+          <p15:clr>
+            <a:srgbClr val="A4A3A4"/>
+          </p15:clr>
+        </p15:guide>
+      </p15:sldGuideLst>
+    </p:ext>
+  </p:extLst>
 </p:presentation>
 </file>
 
@@ -152,10 +168,9 @@
           <a:lstStyle/>
           <a:p>
             <a:r>
-              <a:rPr lang="en-US" smtClean="0"/>
+              <a:rPr lang="en-US"/>
               <a:t>Click to edit Master title style</a:t>
             </a:r>
-            <a:endParaRPr lang="en-US"/>
           </a:p>
         </p:txBody>
       </p:sp>
@@ -271,10 +286,9 @@
           </a:lstStyle>
           <a:p>
             <a:r>
-              <a:rPr lang="en-US" smtClean="0"/>
+              <a:rPr lang="en-US"/>
               <a:t>Click to edit Master subtitle style</a:t>
             </a:r>
-            <a:endParaRPr lang="en-US"/>
           </a:p>
         </p:txBody>
       </p:sp>
@@ -295,7 +309,7 @@
           <a:p>
             <a:fld id="{5BCAD085-E8A6-8845-BD4E-CB4CCA059FC4}" type="datetimeFigureOut">
               <a:rPr lang="en-US" smtClean="0"/>
-              <a:t>1/27/13</a:t>
+              <a:t>9/25/2026</a:t>
             </a:fld>
             <a:endParaRPr lang="en-US"/>
           </a:p>
@@ -389,10 +403,9 @@
           <a:lstStyle/>
           <a:p>
             <a:r>
-              <a:rPr lang="en-US" smtClean="0"/>
+              <a:rPr lang="en-US"/>
               <a:t>Click to edit Master title style</a:t>
             </a:r>
-            <a:endParaRPr lang="en-US"/>
           </a:p>
         </p:txBody>
       </p:sp>
@@ -413,38 +426,37 @@
           <a:p>
             <a:pPr lvl="0"/>
             <a:r>
-              <a:rPr lang="en-US" smtClean="0"/>
+              <a:rPr lang="en-US"/>
               <a:t>Click to edit Master text styles</a:t>
             </a:r>
           </a:p>
           <a:p>
             <a:pPr lvl="1"/>
             <a:r>
-              <a:rPr lang="en-US" smtClean="0"/>
+              <a:rPr lang="en-US"/>
               <a:t>Second level</a:t>
             </a:r>
           </a:p>
           <a:p>
             <a:pPr lvl="2"/>
             <a:r>
-              <a:rPr lang="en-US" smtClean="0"/>
+              <a:rPr lang="en-US"/>
               <a:t>Third level</a:t>
             </a:r>
           </a:p>
           <a:p>
             <a:pPr lvl="3"/>
             <a:r>
-              <a:rPr lang="en-US" smtClean="0"/>
+              <a:rPr lang="en-US"/>
               <a:t>Fourth level</a:t>
             </a:r>
           </a:p>
           <a:p>
             <a:pPr lvl="4"/>
             <a:r>
-              <a:rPr lang="en-US" smtClean="0"/>
+              <a:rPr lang="en-US"/>
               <a:t>Fifth level</a:t>
             </a:r>
-            <a:endParaRPr lang="en-US"/>
           </a:p>
         </p:txBody>
       </p:sp>
@@ -465,7 +477,7 @@
           <a:p>
             <a:fld id="{5BCAD085-E8A6-8845-BD4E-CB4CCA059FC4}" type="datetimeFigureOut">
               <a:rPr lang="en-US" smtClean="0"/>
-              <a:t>1/27/13</a:t>
+              <a:t>9/25/2026</a:t>
             </a:fld>
             <a:endParaRPr lang="en-US"/>
           </a:p>
@@ -564,10 +576,9 @@
           <a:lstStyle/>
           <a:p>
             <a:r>
-              <a:rPr lang="en-US" smtClean="0"/>
+              <a:rPr lang="en-US"/>
               <a:t>Click to edit Master title style</a:t>
             </a:r>
-            <a:endParaRPr lang="en-US"/>
           </a:p>
         </p:txBody>
       </p:sp>
@@ -593,38 +604,37 @@
           <a:p>
             <a:pPr lvl="0"/>
             <a:r>
-              <a:rPr lang="en-US" smtClean="0"/>
+              <a:rPr lang="en-US"/>
               <a:t>Click to edit Master text styles</a:t>
             </a:r>
           </a:p>
           <a:p>
             <a:pPr lvl="1"/>
             <a:r>
-              <a:rPr lang="en-US" smtClean="0"/>
+              <a:rPr lang="en-US"/>
               <a:t>Second level</a:t>
             </a:r>
           </a:p>
           <a:p>
             <a:pPr lvl="2"/>
             <a:r>
-              <a:rPr lang="en-US" smtClean="0"/>
+              <a:rPr lang="en-US"/>
               <a:t>Third level</a:t>
             </a:r>
           </a:p>
           <a:p>
             <a:pPr lvl="3"/>
             <a:r>
-              <a:rPr lang="en-US" smtClean="0"/>
+              <a:rPr lang="en-US"/>
               <a:t>Fourth level</a:t>
             </a:r>
           </a:p>
           <a:p>
             <a:pPr lvl="4"/>
             <a:r>
-              <a:rPr lang="en-US" smtClean="0"/>
+              <a:rPr lang="en-US"/>
               <a:t>Fifth level</a:t>
             </a:r>
-            <a:endParaRPr lang="en-US"/>
           </a:p>
         </p:txBody>
       </p:sp>
@@ -645,7 +655,7 @@
           <a:p>
             <a:fld id="{5BCAD085-E8A6-8845-BD4E-CB4CCA059FC4}" type="datetimeFigureOut">
               <a:rPr lang="en-US" smtClean="0"/>
-              <a:t>1/27/13</a:t>
+              <a:t>9/25/2026</a:t>
             </a:fld>
             <a:endParaRPr lang="en-US"/>
           </a:p>
@@ -739,10 +749,9 @@
           <a:lstStyle/>
           <a:p>
             <a:r>
-              <a:rPr lang="en-US" smtClean="0"/>
+              <a:rPr lang="en-US"/>
               <a:t>Click to edit Master title style</a:t>
             </a:r>
-            <a:endParaRPr lang="en-US"/>
           </a:p>
         </p:txBody>
       </p:sp>
@@ -763,38 +772,37 @@
           <a:p>
             <a:pPr lvl="0"/>
             <a:r>
-              <a:rPr lang="en-US" smtClean="0"/>
+              <a:rPr lang="en-US"/>
               <a:t>Click to edit Master text styles</a:t>
             </a:r>
           </a:p>
           <a:p>
             <a:pPr lvl="1"/>
             <a:r>
-              <a:rPr lang="en-US" smtClean="0"/>
+              <a:rPr lang="en-US"/>
               <a:t>Second level</a:t>
             </a:r>
           </a:p>
           <a:p>
             <a:pPr lvl="2"/>
             <a:r>
-              <a:rPr lang="en-US" smtClean="0"/>
+              <a:rPr lang="en-US"/>
               <a:t>Third level</a:t>
             </a:r>
           </a:p>
           <a:p>
             <a:pPr lvl="3"/>
             <a:r>
-              <a:rPr lang="en-US" smtClean="0"/>
+              <a:rPr lang="en-US"/>
               <a:t>Fourth level</a:t>
             </a:r>
           </a:p>
           <a:p>
             <a:pPr lvl="4"/>
             <a:r>
-              <a:rPr lang="en-US" smtClean="0"/>
+              <a:rPr lang="en-US"/>
               <a:t>Fifth level</a:t>
             </a:r>
-            <a:endParaRPr lang="en-US"/>
           </a:p>
         </p:txBody>
       </p:sp>
@@ -815,7 +823,7 @@
           <a:p>
             <a:fld id="{5BCAD085-E8A6-8845-BD4E-CB4CCA059FC4}" type="datetimeFigureOut">
               <a:rPr lang="en-US" smtClean="0"/>
-              <a:t>1/27/13</a:t>
+              <a:t>9/25/2026</a:t>
             </a:fld>
             <a:endParaRPr lang="en-US"/>
           </a:p>
@@ -918,10 +926,9 @@
           </a:lstStyle>
           <a:p>
             <a:r>
-              <a:rPr lang="en-US" smtClean="0"/>
+              <a:rPr lang="en-US"/>
               <a:t>Click to edit Master title style</a:t>
             </a:r>
-            <a:endParaRPr lang="en-US"/>
           </a:p>
         </p:txBody>
       </p:sp>
@@ -1038,7 +1045,7 @@
           <a:p>
             <a:pPr lvl="0"/>
             <a:r>
-              <a:rPr lang="en-US" smtClean="0"/>
+              <a:rPr lang="en-US"/>
               <a:t>Click to edit Master text styles</a:t>
             </a:r>
           </a:p>
@@ -1061,7 +1068,7 @@
           <a:p>
             <a:fld id="{5BCAD085-E8A6-8845-BD4E-CB4CCA059FC4}" type="datetimeFigureOut">
               <a:rPr lang="en-US" smtClean="0"/>
-              <a:t>1/27/13</a:t>
+              <a:t>9/25/2026</a:t>
             </a:fld>
             <a:endParaRPr lang="en-US"/>
           </a:p>
@@ -1155,10 +1162,9 @@
           <a:lstStyle/>
           <a:p>
             <a:r>
-              <a:rPr lang="en-US" smtClean="0"/>
+              <a:rPr lang="en-US"/>
               <a:t>Click to edit Master title style</a:t>
             </a:r>
-            <a:endParaRPr lang="en-US"/>
           </a:p>
         </p:txBody>
       </p:sp>
@@ -1212,38 +1218,37 @@
           <a:p>
             <a:pPr lvl="0"/>
             <a:r>
-              <a:rPr lang="en-US" smtClean="0"/>
+              <a:rPr lang="en-US"/>
               <a:t>Click to edit Master text styles</a:t>
             </a:r>
           </a:p>
           <a:p>
             <a:pPr lvl="1"/>
             <a:r>
-              <a:rPr lang="en-US" smtClean="0"/>
+              <a:rPr lang="en-US"/>
               <a:t>Second level</a:t>
             </a:r>
           </a:p>
           <a:p>
             <a:pPr lvl="2"/>
             <a:r>
-              <a:rPr lang="en-US" smtClean="0"/>
+              <a:rPr lang="en-US"/>
               <a:t>Third level</a:t>
             </a:r>
           </a:p>
           <a:p>
             <a:pPr lvl="3"/>
             <a:r>
-              <a:rPr lang="en-US" smtClean="0"/>
+              <a:rPr lang="en-US"/>
               <a:t>Fourth level</a:t>
             </a:r>
           </a:p>
           <a:p>
             <a:pPr lvl="4"/>
             <a:r>
-              <a:rPr lang="en-US" smtClean="0"/>
+              <a:rPr lang="en-US"/>
               <a:t>Fifth level</a:t>
             </a:r>
-            <a:endParaRPr lang="en-US"/>
           </a:p>
         </p:txBody>
       </p:sp>
@@ -1297,38 +1302,37 @@
           <a:p>
             <a:pPr lvl="0"/>
             <a:r>
-              <a:rPr lang="en-US" smtClean="0"/>
+              <a:rPr lang="en-US"/>
               <a:t>Click to edit Master text styles</a:t>
             </a:r>
           </a:p>
           <a:p>
             <a:pPr lvl="1"/>
             <a:r>
-              <a:rPr lang="en-US" smtClean="0"/>
+              <a:rPr lang="en-US"/>
               <a:t>Second level</a:t>
             </a:r>
           </a:p>
           <a:p>
             <a:pPr lvl="2"/>
             <a:r>
-              <a:rPr lang="en-US" smtClean="0"/>
+              <a:rPr lang="en-US"/>
               <a:t>Third level</a:t>
             </a:r>
           </a:p>
           <a:p>
             <a:pPr lvl="3"/>
             <a:r>
-              <a:rPr lang="en-US" smtClean="0"/>
+              <a:rPr lang="en-US"/>
               <a:t>Fourth level</a:t>
             </a:r>
           </a:p>
           <a:p>
             <a:pPr lvl="4"/>
             <a:r>
-              <a:rPr lang="en-US" smtClean="0"/>
+              <a:rPr lang="en-US"/>
               <a:t>Fifth level</a:t>
             </a:r>
-            <a:endParaRPr lang="en-US"/>
           </a:p>
         </p:txBody>
       </p:sp>
@@ -1349,7 +1353,7 @@
           <a:p>
             <a:fld id="{5BCAD085-E8A6-8845-BD4E-CB4CCA059FC4}" type="datetimeFigureOut">
               <a:rPr lang="en-US" smtClean="0"/>
-              <a:t>1/27/13</a:t>
+              <a:t>9/25/2026</a:t>
             </a:fld>
             <a:endParaRPr lang="en-US"/>
           </a:p>
@@ -1447,10 +1451,9 @@
           </a:lstStyle>
           <a:p>
             <a:r>
-              <a:rPr lang="en-US" smtClean="0"/>
+              <a:rPr lang="en-US"/>
               <a:t>Click to edit Master title style</a:t>
             </a:r>
-            <a:endParaRPr lang="en-US"/>
           </a:p>
         </p:txBody>
       </p:sp>
@@ -1513,7 +1516,7 @@
           <a:p>
             <a:pPr lvl="0"/>
             <a:r>
-              <a:rPr lang="en-US" smtClean="0"/>
+              <a:rPr lang="en-US"/>
               <a:t>Click to edit Master text styles</a:t>
             </a:r>
           </a:p>
@@ -1569,38 +1572,37 @@
           <a:p>
             <a:pPr lvl="0"/>
             <a:r>
-              <a:rPr lang="en-US" smtClean="0"/>
+              <a:rPr lang="en-US"/>
               <a:t>Click to edit Master text styles</a:t>
             </a:r>
           </a:p>
           <a:p>
             <a:pPr lvl="1"/>
             <a:r>
-              <a:rPr lang="en-US" smtClean="0"/>
+              <a:rPr lang="en-US"/>
               <a:t>Second level</a:t>
             </a:r>
           </a:p>
           <a:p>
             <a:pPr lvl="2"/>
             <a:r>
-              <a:rPr lang="en-US" smtClean="0"/>
+              <a:rPr lang="en-US"/>
               <a:t>Third level</a:t>
             </a:r>
           </a:p>
           <a:p>
             <a:pPr lvl="3"/>
             <a:r>
-              <a:rPr lang="en-US" smtClean="0"/>
+              <a:rPr lang="en-US"/>
               <a:t>Fourth level</a:t>
             </a:r>
           </a:p>
           <a:p>
             <a:pPr lvl="4"/>
             <a:r>
-              <a:rPr lang="en-US" smtClean="0"/>
+              <a:rPr lang="en-US"/>
               <a:t>Fifth level</a:t>
             </a:r>
-            <a:endParaRPr lang="en-US"/>
           </a:p>
         </p:txBody>
       </p:sp>
@@ -1663,7 +1665,7 @@
           <a:p>
             <a:pPr lvl="0"/>
             <a:r>
-              <a:rPr lang="en-US" smtClean="0"/>
+              <a:rPr lang="en-US"/>
               <a:t>Click to edit Master text styles</a:t>
             </a:r>
           </a:p>
@@ -1719,38 +1721,37 @@
           <a:p>
             <a:pPr lvl="0"/>
             <a:r>
-              <a:rPr lang="en-US" smtClean="0"/>
+              <a:rPr lang="en-US"/>
               <a:t>Click to edit Master text styles</a:t>
             </a:r>
           </a:p>
           <a:p>
             <a:pPr lvl="1"/>
             <a:r>
-              <a:rPr lang="en-US" smtClean="0"/>
+              <a:rPr lang="en-US"/>
               <a:t>Second level</a:t>
             </a:r>
           </a:p>
           <a:p>
             <a:pPr lvl="2"/>
             <a:r>
-              <a:rPr lang="en-US" smtClean="0"/>
+              <a:rPr lang="en-US"/>
               <a:t>Third level</a:t>
             </a:r>
           </a:p>
           <a:p>
             <a:pPr lvl="3"/>
             <a:r>
-              <a:rPr lang="en-US" smtClean="0"/>
+              <a:rPr lang="en-US"/>
               <a:t>Fourth level</a:t>
             </a:r>
           </a:p>
           <a:p>
             <a:pPr lvl="4"/>
             <a:r>
-              <a:rPr lang="en-US" smtClean="0"/>
+              <a:rPr lang="en-US"/>
               <a:t>Fifth level</a:t>
             </a:r>
-            <a:endParaRPr lang="en-US"/>
           </a:p>
         </p:txBody>
       </p:sp>
@@ -1771,7 +1772,7 @@
           <a:p>
             <a:fld id="{5BCAD085-E8A6-8845-BD4E-CB4CCA059FC4}" type="datetimeFigureOut">
               <a:rPr lang="en-US" smtClean="0"/>
-              <a:t>1/27/13</a:t>
+              <a:t>9/25/2026</a:t>
             </a:fld>
             <a:endParaRPr lang="en-US"/>
           </a:p>
@@ -1865,10 +1866,9 @@
           <a:lstStyle/>
           <a:p>
             <a:r>
-              <a:rPr lang="en-US" smtClean="0"/>
+              <a:rPr lang="en-US"/>
               <a:t>Click to edit Master title style</a:t>
             </a:r>
-            <a:endParaRPr lang="en-US"/>
           </a:p>
         </p:txBody>
       </p:sp>
@@ -1889,7 +1889,7 @@
           <a:p>
             <a:fld id="{5BCAD085-E8A6-8845-BD4E-CB4CCA059FC4}" type="datetimeFigureOut">
               <a:rPr lang="en-US" smtClean="0"/>
-              <a:t>1/27/13</a:t>
+              <a:t>9/25/2026</a:t>
             </a:fld>
             <a:endParaRPr lang="en-US"/>
           </a:p>
@@ -1984,7 +1984,7 @@
           <a:p>
             <a:fld id="{5BCAD085-E8A6-8845-BD4E-CB4CCA059FC4}" type="datetimeFigureOut">
               <a:rPr lang="en-US" smtClean="0"/>
-              <a:t>1/27/13</a:t>
+              <a:t>9/25/2026</a:t>
             </a:fld>
             <a:endParaRPr lang="en-US"/>
           </a:p>
@@ -2087,10 +2087,9 @@
           </a:lstStyle>
           <a:p>
             <a:r>
-              <a:rPr lang="en-US" smtClean="0"/>
+              <a:rPr lang="en-US"/>
               <a:t>Click to edit Master title style</a:t>
             </a:r>
-            <a:endParaRPr lang="en-US"/>
           </a:p>
         </p:txBody>
       </p:sp>
@@ -2144,38 +2143,37 @@
           <a:p>
             <a:pPr lvl="0"/>
             <a:r>
-              <a:rPr lang="en-US" smtClean="0"/>
+              <a:rPr lang="en-US"/>
               <a:t>Click to edit Master text styles</a:t>
             </a:r>
           </a:p>
           <a:p>
             <a:pPr lvl="1"/>
             <a:r>
-              <a:rPr lang="en-US" smtClean="0"/>
+              <a:rPr lang="en-US"/>
               <a:t>Second level</a:t>
             </a:r>
           </a:p>
           <a:p>
             <a:pPr lvl="2"/>
             <a:r>
-              <a:rPr lang="en-US" smtClean="0"/>
+              <a:rPr lang="en-US"/>
               <a:t>Third level</a:t>
             </a:r>
           </a:p>
           <a:p>
             <a:pPr lvl="3"/>
             <a:r>
-              <a:rPr lang="en-US" smtClean="0"/>
+              <a:rPr lang="en-US"/>
               <a:t>Fourth level</a:t>
             </a:r>
           </a:p>
           <a:p>
             <a:pPr lvl="4"/>
             <a:r>
-              <a:rPr lang="en-US" smtClean="0"/>
+              <a:rPr lang="en-US"/>
               <a:t>Fifth level</a:t>
             </a:r>
-            <a:endParaRPr lang="en-US"/>
           </a:p>
         </p:txBody>
       </p:sp>
@@ -2238,7 +2236,7 @@
           <a:p>
             <a:pPr lvl="0"/>
             <a:r>
-              <a:rPr lang="en-US" smtClean="0"/>
+              <a:rPr lang="en-US"/>
               <a:t>Click to edit Master text styles</a:t>
             </a:r>
           </a:p>
@@ -2261,7 +2259,7 @@
           <a:p>
             <a:fld id="{5BCAD085-E8A6-8845-BD4E-CB4CCA059FC4}" type="datetimeFigureOut">
               <a:rPr lang="en-US" smtClean="0"/>
-              <a:t>1/27/13</a:t>
+              <a:t>9/25/2026</a:t>
             </a:fld>
             <a:endParaRPr lang="en-US"/>
           </a:p>
@@ -2364,10 +2362,9 @@
           </a:lstStyle>
           <a:p>
             <a:r>
-              <a:rPr lang="en-US" smtClean="0"/>
+              <a:rPr lang="en-US"/>
               <a:t>Click to edit Master title style</a:t>
             </a:r>
-            <a:endParaRPr lang="en-US"/>
           </a:p>
         </p:txBody>
       </p:sp>
@@ -2491,7 +2488,7 @@
           <a:p>
             <a:pPr lvl="0"/>
             <a:r>
-              <a:rPr lang="en-US" smtClean="0"/>
+              <a:rPr lang="en-US"/>
               <a:t>Click to edit Master text styles</a:t>
             </a:r>
           </a:p>
@@ -2514,7 +2511,7 @@
           <a:p>
             <a:fld id="{5BCAD085-E8A6-8845-BD4E-CB4CCA059FC4}" type="datetimeFigureOut">
               <a:rPr lang="en-US" smtClean="0"/>
-              <a:t>1/27/13</a:t>
+              <a:t>9/25/2026</a:t>
             </a:fld>
             <a:endParaRPr lang="en-US"/>
           </a:p>
@@ -2623,10 +2620,9 @@
           <a:lstStyle/>
           <a:p>
             <a:r>
-              <a:rPr lang="en-US" smtClean="0"/>
+              <a:rPr lang="en-US"/>
               <a:t>Click to edit Master title style</a:t>
             </a:r>
-            <a:endParaRPr lang="en-US"/>
           </a:p>
         </p:txBody>
       </p:sp>
@@ -2657,38 +2653,37 @@
           <a:p>
             <a:pPr lvl="0"/>
             <a:r>
-              <a:rPr lang="en-US" smtClean="0"/>
+              <a:rPr lang="en-US"/>
               <a:t>Click to edit Master text styles</a:t>
             </a:r>
           </a:p>
           <a:p>
             <a:pPr lvl="1"/>
             <a:r>
-              <a:rPr lang="en-US" smtClean="0"/>
+              <a:rPr lang="en-US"/>
               <a:t>Second level</a:t>
             </a:r>
           </a:p>
           <a:p>
             <a:pPr lvl="2"/>
             <a:r>
-              <a:rPr lang="en-US" smtClean="0"/>
+              <a:rPr lang="en-US"/>
               <a:t>Third level</a:t>
             </a:r>
           </a:p>
           <a:p>
             <a:pPr lvl="3"/>
             <a:r>
-              <a:rPr lang="en-US" smtClean="0"/>
+              <a:rPr lang="en-US"/>
               <a:t>Fourth level</a:t>
             </a:r>
           </a:p>
           <a:p>
             <a:pPr lvl="4"/>
             <a:r>
-              <a:rPr lang="en-US" smtClean="0"/>
+              <a:rPr lang="en-US"/>
               <a:t>Fifth level</a:t>
             </a:r>
-            <a:endParaRPr lang="en-US"/>
           </a:p>
         </p:txBody>
       </p:sp>
@@ -2727,7 +2722,7 @@
           <a:p>
             <a:fld id="{5BCAD085-E8A6-8845-BD4E-CB4CCA059FC4}" type="datetimeFigureOut">
               <a:rPr lang="en-US" smtClean="0"/>
-              <a:t>1/27/13</a:t>
+              <a:t>9/25/2026</a:t>
             </a:fld>
             <a:endParaRPr lang="en-US"/>
           </a:p>
@@ -3086,7 +3081,7 @@
 </file>
 
 <file path=ppt/slides/slide1.xml><?xml version="1.0" encoding="utf-8"?>
-<p:sld xmlns:a="http://schemas.openxmlformats.org/drawingml/2006/main" xmlns:p="http://schemas.openxmlformats.org/presentationml/2006/main" xmlns:r="http://schemas.openxmlformats.org/officeDocument/2006/relationships">
+<p:sld xmlns:a="http://schemas.openxmlformats.org/drawingml/2006/main" xmlns:r="http://schemas.openxmlformats.org/officeDocument/2006/relationships" xmlns:p="http://schemas.openxmlformats.org/presentationml/2006/main">
   <p:cSld>
     <p:spTree>
       <p:nvGrpSpPr>
@@ -3094,7 +3089,14 @@
         <p:cNvGrpSpPr/>
         <p:nvPr/>
       </p:nvGrpSpPr>
-      <p:grpSpPr/>
+      <p:grpSpPr>
+        <a:xfrm>
+          <a:off x="0" y="0"/>
+          <a:ext cx="0" cy="0"/>
+          <a:chOff x="0" y="0"/>
+          <a:chExt cx="0" cy="0"/>
+        </a:xfrm>
+      </p:grpSpPr>
       <p:sp>
         <p:nvSpPr>
           <p:cNvPr id="2" name="TextBox 1"/>
@@ -3271,7 +3273,7 @@
           </a:fontRef>
         </p:style>
         <p:txBody>
-          <a:bodyPr rtlCol="0" anchor="ctr" wrap="square"/>
+          <a:bodyPr wrap="square" rtlCol="0" anchor="ctr"/>
           <a:lstStyle/>
           <a:p>
             <a:pPr algn="ctr"/>
@@ -3359,7 +3361,7 @@
           </a:fontRef>
         </p:style>
         <p:txBody>
-          <a:bodyPr rtlCol="0" anchor="ctr" wrap="square"/>
+          <a:bodyPr wrap="square" rtlCol="0" anchor="ctr"/>
           <a:lstStyle/>
           <a:p>
             <a:pPr algn="ctr"/>
@@ -3447,7 +3449,7 @@
           </a:fontRef>
         </p:style>
         <p:txBody>
-          <a:bodyPr rtlCol="0" anchor="ctr" wrap="square"/>
+          <a:bodyPr wrap="square" rtlCol="0" anchor="ctr"/>
           <a:lstStyle/>
           <a:p>
             <a:pPr algn="ctr"/>
@@ -3535,7 +3537,7 @@
           </a:fontRef>
         </p:style>
         <p:txBody>
-          <a:bodyPr rtlCol="0" anchor="ctr" wrap="square"/>
+          <a:bodyPr wrap="square" rtlCol="0" anchor="ctr"/>
           <a:lstStyle/>
           <a:p>
             <a:pPr algn="ctr"/>
@@ -3623,7 +3625,7 @@
           </a:fontRef>
         </p:style>
         <p:txBody>
-          <a:bodyPr rtlCol="0" anchor="ctr" wrap="square"/>
+          <a:bodyPr wrap="square" rtlCol="0" anchor="ctr"/>
           <a:lstStyle/>
           <a:p>
             <a:pPr algn="ctr"/>
@@ -3695,7 +3697,7 @@
 </file>
 
 <file path=ppt/slides/slide2.xml><?xml version="1.0" encoding="utf-8"?>
-<p:sld xmlns:a="http://schemas.openxmlformats.org/drawingml/2006/main" xmlns:p="http://schemas.openxmlformats.org/presentationml/2006/main" xmlns:r="http://schemas.openxmlformats.org/officeDocument/2006/relationships">
+<p:sld xmlns:a="http://schemas.openxmlformats.org/drawingml/2006/main" xmlns:r="http://schemas.openxmlformats.org/officeDocument/2006/relationships" xmlns:p="http://schemas.openxmlformats.org/presentationml/2006/main">
   <p:cSld>
     <p:spTree>
       <p:nvGrpSpPr>
@@ -3703,7 +3705,14 @@
         <p:cNvGrpSpPr/>
         <p:nvPr/>
       </p:nvGrpSpPr>
-      <p:grpSpPr/>
+      <p:grpSpPr>
+        <a:xfrm>
+          <a:off x="0" y="0"/>
+          <a:ext cx="0" cy="0"/>
+          <a:chOff x="0" y="0"/>
+          <a:chExt cx="0" cy="0"/>
+        </a:xfrm>
+      </p:grpSpPr>
       <p:sp>
         <p:nvSpPr>
           <p:cNvPr id="2" name="TextBox 1"/>
@@ -3748,7 +3757,7 @@
         <p:spPr>
           <a:xfrm>
             <a:off x="548640" y="914400"/>
-            <a:ext cx="10972800" cy="457200"/>
+            <a:ext cx="10972800" cy="323165"/>
           </a:xfrm>
           <a:prstGeom prst="rect">
             <a:avLst/>
@@ -3763,13 +3772,13 @@
           <a:p>
             <a:pPr algn="l"/>
             <a:r>
-              <a:rPr sz="1500" b="0">
+              <a:rPr sz="1500" b="0" dirty="0">
                 <a:solidFill>
                   <a:srgbClr val="52514E"/>
                 </a:solidFill>
                 <a:latin typeface="Calibri"/>
               </a:rPr>
-              <a:t>Sprint 1 - completed and verified</a:t>
+              <a:t>Sprint 1</a:t>
             </a:r>
           </a:p>
         </p:txBody>
@@ -4090,7 +4099,7 @@
           </a:fontRef>
         </p:style>
         <p:txBody>
-          <a:bodyPr rtlCol="0" anchor="ctr" wrap="square"/>
+          <a:bodyPr wrap="square" rtlCol="0" anchor="ctr"/>
           <a:lstStyle/>
           <a:p>
             <a:pPr algn="ctr"/>
@@ -4154,7 +4163,7 @@
           </a:fontRef>
         </p:style>
         <p:txBody>
-          <a:bodyPr rtlCol="0" anchor="ctr" wrap="square"/>
+          <a:bodyPr wrap="square" rtlCol="0" anchor="ctr"/>
           <a:lstStyle/>
           <a:p>
             <a:pPr algn="ctr"/>
@@ -4218,7 +4227,7 @@
           </a:fontRef>
         </p:style>
         <p:txBody>
-          <a:bodyPr rtlCol="0" anchor="ctr" wrap="square"/>
+          <a:bodyPr wrap="square" rtlCol="0" anchor="ctr"/>
           <a:lstStyle/>
           <a:p>
             <a:pPr algn="ctr"/>
@@ -4282,7 +4291,7 @@
           </a:fontRef>
         </p:style>
         <p:txBody>
-          <a:bodyPr rtlCol="0" anchor="ctr" wrap="square"/>
+          <a:bodyPr wrap="square" rtlCol="0" anchor="ctr"/>
           <a:lstStyle/>
           <a:p>
             <a:pPr algn="ctr"/>
@@ -4346,7 +4355,7 @@
           </a:fontRef>
         </p:style>
         <p:txBody>
-          <a:bodyPr rtlCol="0" anchor="ctr" wrap="square"/>
+          <a:bodyPr wrap="square" rtlCol="0" anchor="ctr"/>
           <a:lstStyle/>
           <a:p>
             <a:pPr algn="ctr"/>
@@ -4410,7 +4419,7 @@
           </a:fontRef>
         </p:style>
         <p:txBody>
-          <a:bodyPr rtlCol="0" anchor="ctr" wrap="square"/>
+          <a:bodyPr wrap="square" rtlCol="0" anchor="ctr"/>
           <a:lstStyle/>
           <a:p>
             <a:pPr algn="ctr"/>
@@ -4434,41 +4443,6 @@
                 <a:latin typeface="Calibri"/>
               </a:rPr>
               <a:t>21/21 acceptance checks</a:t>
-            </a:r>
-          </a:p>
-        </p:txBody>
-      </p:sp>
-      <p:sp>
-        <p:nvSpPr>
-          <p:cNvPr id="18" name="TextBox 17"/>
-          <p:cNvSpPr txBox="1"/>
-          <p:nvPr/>
-        </p:nvSpPr>
-        <p:spPr>
-          <a:xfrm>
-            <a:off x="731520" y="5989320"/>
-            <a:ext cx="10972800" cy="365760"/>
-          </a:xfrm>
-          <a:prstGeom prst="rect">
-            <a:avLst/>
-          </a:prstGeom>
-          <a:noFill/>
-        </p:spPr>
-        <p:txBody>
-          <a:bodyPr wrap="square">
-            <a:spAutoFit/>
-          </a:bodyPr>
-          <a:lstStyle/>
-          <a:p>
-            <a:pPr algn="l"/>
-            <a:r>
-              <a:rPr sz="1000" b="0">
-                <a:solidFill>
-                  <a:srgbClr val="8A8984"/>
-                </a:solidFill>
-                <a:latin typeface="Calibri"/>
-              </a:rPr>
-              <a:t>Unique count corrected 4,037 -&gt; 4,029 after an HTML-decoding fix revealed 8 hidden duplicates (docs/sprint1_bugfix_log.md). Raw and canonical counts unchanged.</a:t>
             </a:r>
           </a:p>
         </p:txBody>
@@ -4482,7 +4456,7 @@
 </file>
 
 <file path=ppt/slides/slide3.xml><?xml version="1.0" encoding="utf-8"?>
-<p:sld xmlns:a="http://schemas.openxmlformats.org/drawingml/2006/main" xmlns:p="http://schemas.openxmlformats.org/presentationml/2006/main" xmlns:r="http://schemas.openxmlformats.org/officeDocument/2006/relationships">
+<p:sld xmlns:a="http://schemas.openxmlformats.org/drawingml/2006/main" xmlns:r="http://schemas.openxmlformats.org/officeDocument/2006/relationships" xmlns:p="http://schemas.openxmlformats.org/presentationml/2006/main">
   <p:cSld>
     <p:spTree>
       <p:nvGrpSpPr>
@@ -4490,7 +4464,14 @@
         <p:cNvGrpSpPr/>
         <p:nvPr/>
       </p:nvGrpSpPr>
-      <p:grpSpPr/>
+      <p:grpSpPr>
+        <a:xfrm>
+          <a:off x="0" y="0"/>
+          <a:ext cx="0" cy="0"/>
+          <a:chOff x="0" y="0"/>
+          <a:chExt cx="0" cy="0"/>
+        </a:xfrm>
+      </p:grpSpPr>
       <p:sp>
         <p:nvSpPr>
           <p:cNvPr id="2" name="TextBox 1"/>
@@ -4667,7 +4648,7 @@
           </a:fontRef>
         </p:style>
         <p:txBody>
-          <a:bodyPr rtlCol="0" anchor="ctr" wrap="square"/>
+          <a:bodyPr wrap="square" rtlCol="0" anchor="ctr"/>
           <a:lstStyle/>
           <a:p>
             <a:pPr algn="ctr"/>
@@ -4731,7 +4712,7 @@
           </a:fontRef>
         </p:style>
         <p:txBody>
-          <a:bodyPr rtlCol="0" anchor="ctr" wrap="square"/>
+          <a:bodyPr wrap="square" rtlCol="0" anchor="ctr"/>
           <a:lstStyle/>
           <a:p>
             <a:pPr algn="ctr"/>
@@ -4797,7 +4778,7 @@
           </a:fontRef>
         </p:style>
         <p:txBody>
-          <a:bodyPr rtlCol="0" anchor="ctr" wrap="square"/>
+          <a:bodyPr wrap="square" rtlCol="0" anchor="ctr"/>
           <a:lstStyle/>
           <a:p>
             <a:pPr algn="ctr"/>
@@ -4933,7 +4914,7 @@
           </a:fontRef>
         </p:style>
         <p:txBody>
-          <a:bodyPr rtlCol="0" anchor="ctr" wrap="square"/>
+          <a:bodyPr wrap="square" rtlCol="0" anchor="ctr"/>
           <a:lstStyle/>
           <a:p>
             <a:pPr algn="ctr"/>
@@ -5021,7 +5002,7 @@
           </a:fontRef>
         </p:style>
         <p:txBody>
-          <a:bodyPr rtlCol="0" anchor="ctr" wrap="square"/>
+          <a:bodyPr wrap="square" rtlCol="0" anchor="ctr"/>
           <a:lstStyle/>
           <a:p>
             <a:pPr algn="ctr"/>
@@ -5073,7 +5054,7 @@
           </a:fontRef>
         </p:style>
         <p:txBody>
-          <a:bodyPr rtlCol="0" anchor="ctr" wrap="square"/>
+          <a:bodyPr wrap="square" rtlCol="0" anchor="ctr"/>
           <a:lstStyle/>
           <a:p>
             <a:pPr algn="ctr"/>
@@ -5197,7 +5178,7 @@
           </a:fontRef>
         </p:style>
         <p:txBody>
-          <a:bodyPr rtlCol="0" anchor="ctr" wrap="square"/>
+          <a:bodyPr wrap="square" rtlCol="0" anchor="ctr"/>
           <a:lstStyle/>
           <a:p>
             <a:pPr algn="ctr"/>
@@ -5261,7 +5242,7 @@
           </a:fontRef>
         </p:style>
         <p:txBody>
-          <a:bodyPr rtlCol="0" anchor="ctr" wrap="square"/>
+          <a:bodyPr wrap="square" rtlCol="0" anchor="ctr"/>
           <a:lstStyle/>
           <a:p>
             <a:pPr algn="ctr"/>
@@ -5417,7 +5398,7 @@
 </file>
 
 <file path=ppt/slides/slide4.xml><?xml version="1.0" encoding="utf-8"?>
-<p:sld xmlns:a="http://schemas.openxmlformats.org/drawingml/2006/main" xmlns:p="http://schemas.openxmlformats.org/presentationml/2006/main" xmlns:r="http://schemas.openxmlformats.org/officeDocument/2006/relationships">
+<p:sld xmlns:a="http://schemas.openxmlformats.org/drawingml/2006/main" xmlns:r="http://schemas.openxmlformats.org/officeDocument/2006/relationships" xmlns:p="http://schemas.openxmlformats.org/presentationml/2006/main">
   <p:cSld>
     <p:spTree>
       <p:nvGrpSpPr>
@@ -5425,7 +5406,14 @@
         <p:cNvGrpSpPr/>
         <p:nvPr/>
       </p:nvGrpSpPr>
-      <p:grpSpPr/>
+      <p:grpSpPr>
+        <a:xfrm>
+          <a:off x="0" y="0"/>
+          <a:ext cx="0" cy="0"/>
+          <a:chOff x="0" y="0"/>
+          <a:chExt cx="0" cy="0"/>
+        </a:xfrm>
+      </p:grpSpPr>
       <p:sp>
         <p:nvSpPr>
           <p:cNvPr id="2" name="TextBox 1"/>
@@ -5485,7 +5473,7 @@
           <a:p>
             <a:pPr algn="l"/>
             <a:r>
-              <a:rPr sz="1500" b="0">
+              <a:rPr sz="1500" b="0" dirty="0">
                 <a:solidFill>
                   <a:srgbClr val="52514E"/>
                 </a:solidFill>
@@ -5997,7 +5985,7 @@
 </file>
 
 <file path=ppt/slides/slide5.xml><?xml version="1.0" encoding="utf-8"?>
-<p:sld xmlns:a="http://schemas.openxmlformats.org/drawingml/2006/main" xmlns:p="http://schemas.openxmlformats.org/presentationml/2006/main" xmlns:r="http://schemas.openxmlformats.org/officeDocument/2006/relationships">
+<p:sld xmlns:a="http://schemas.openxmlformats.org/drawingml/2006/main" xmlns:r="http://schemas.openxmlformats.org/officeDocument/2006/relationships" xmlns:p="http://schemas.openxmlformats.org/presentationml/2006/main">
   <p:cSld>
     <p:spTree>
       <p:nvGrpSpPr>
@@ -6005,7 +5993,14 @@
         <p:cNvGrpSpPr/>
         <p:nvPr/>
       </p:nvGrpSpPr>
-      <p:grpSpPr/>
+      <p:grpSpPr>
+        <a:xfrm>
+          <a:off x="0" y="0"/>
+          <a:ext cx="0" cy="0"/>
+          <a:chOff x="0" y="0"/>
+          <a:chExt cx="0" cy="0"/>
+        </a:xfrm>
+      </p:grpSpPr>
       <p:sp>
         <p:nvSpPr>
           <p:cNvPr id="2" name="TextBox 1"/>
@@ -6182,7 +6177,7 @@
           </a:fontRef>
         </p:style>
         <p:txBody>
-          <a:bodyPr rtlCol="0" anchor="ctr" wrap="square"/>
+          <a:bodyPr wrap="square" rtlCol="0" anchor="ctr"/>
           <a:lstStyle/>
           <a:p>
             <a:pPr algn="ctr"/>
@@ -6234,7 +6229,7 @@
           </a:fontRef>
         </p:style>
         <p:txBody>
-          <a:bodyPr rtlCol="0" anchor="ctr" wrap="square"/>
+          <a:bodyPr wrap="square" rtlCol="0" anchor="ctr"/>
           <a:lstStyle/>
           <a:p>
             <a:pPr algn="ctr"/>
@@ -6286,7 +6281,7 @@
           </a:fontRef>
         </p:style>
         <p:txBody>
-          <a:bodyPr rtlCol="0" anchor="ctr" wrap="square"/>
+          <a:bodyPr wrap="square" rtlCol="0" anchor="ctr"/>
           <a:lstStyle/>
           <a:p>
             <a:pPr algn="ctr"/>
@@ -6338,7 +6333,7 @@
           </a:fontRef>
         </p:style>
         <p:txBody>
-          <a:bodyPr rtlCol="0" anchor="ctr" wrap="square"/>
+          <a:bodyPr wrap="square" rtlCol="0" anchor="ctr"/>
           <a:lstStyle/>
           <a:p>
             <a:pPr algn="ctr"/>
@@ -6402,7 +6397,7 @@
           </a:fontRef>
         </p:style>
         <p:txBody>
-          <a:bodyPr rtlCol="0" anchor="ctr" wrap="square"/>
+          <a:bodyPr wrap="square" rtlCol="0" anchor="ctr"/>
           <a:lstStyle/>
           <a:p>
             <a:pPr algn="ctr"/>
@@ -6466,7 +6461,7 @@
           </a:fontRef>
         </p:style>
         <p:txBody>
-          <a:bodyPr rtlCol="0" anchor="ctr" wrap="square"/>
+          <a:bodyPr wrap="square" rtlCol="0" anchor="ctr"/>
           <a:lstStyle/>
           <a:p>
             <a:pPr algn="ctr"/>
@@ -6602,7 +6597,7 @@
           </a:fontRef>
         </p:style>
         <p:txBody>
-          <a:bodyPr rtlCol="0" anchor="ctr" wrap="square"/>
+          <a:bodyPr wrap="square" rtlCol="0" anchor="ctr"/>
           <a:lstStyle/>
           <a:p>
             <a:pPr algn="ctr"/>
@@ -6758,7 +6753,7 @@
 </file>
 
 <file path=ppt/slides/slide6.xml><?xml version="1.0" encoding="utf-8"?>
-<p:sld xmlns:a="http://schemas.openxmlformats.org/drawingml/2006/main" xmlns:p="http://schemas.openxmlformats.org/presentationml/2006/main" xmlns:r="http://schemas.openxmlformats.org/officeDocument/2006/relationships">
+<p:sld xmlns:a="http://schemas.openxmlformats.org/drawingml/2006/main" xmlns:r="http://schemas.openxmlformats.org/officeDocument/2006/relationships" xmlns:p="http://schemas.openxmlformats.org/presentationml/2006/main">
   <p:cSld>
     <p:spTree>
       <p:nvGrpSpPr>
@@ -6766,7 +6761,14 @@
         <p:cNvGrpSpPr/>
         <p:nvPr/>
       </p:nvGrpSpPr>
-      <p:grpSpPr/>
+      <p:grpSpPr>
+        <a:xfrm>
+          <a:off x="0" y="0"/>
+          <a:ext cx="0" cy="0"/>
+          <a:chOff x="0" y="0"/>
+          <a:chExt cx="0" cy="0"/>
+        </a:xfrm>
+      </p:grpSpPr>
       <p:sp>
         <p:nvSpPr>
           <p:cNvPr id="2" name="TextBox 1"/>
@@ -6943,7 +6945,7 @@
           </a:fontRef>
         </p:style>
         <p:txBody>
-          <a:bodyPr rtlCol="0" anchor="ctr" wrap="square"/>
+          <a:bodyPr wrap="square" rtlCol="0" anchor="ctr"/>
           <a:lstStyle/>
           <a:p>
             <a:pPr algn="ctr"/>
@@ -6995,7 +6997,7 @@
           </a:fontRef>
         </p:style>
         <p:txBody>
-          <a:bodyPr rtlCol="0" anchor="ctr" wrap="square"/>
+          <a:bodyPr wrap="square" rtlCol="0" anchor="ctr"/>
           <a:lstStyle/>
           <a:p>
             <a:pPr algn="ctr"/>
@@ -7083,7 +7085,7 @@
           </a:fontRef>
         </p:style>
         <p:txBody>
-          <a:bodyPr rtlCol="0" anchor="ctr" wrap="square"/>
+          <a:bodyPr wrap="square" rtlCol="0" anchor="ctr"/>
           <a:lstStyle/>
           <a:p>
             <a:pPr algn="ctr"/>
@@ -7135,7 +7137,7 @@
           </a:fontRef>
         </p:style>
         <p:txBody>
-          <a:bodyPr rtlCol="0" anchor="ctr" wrap="square"/>
+          <a:bodyPr wrap="square" rtlCol="0" anchor="ctr"/>
           <a:lstStyle/>
           <a:p>
             <a:pPr algn="ctr"/>
@@ -7223,7 +7225,7 @@
           </a:fontRef>
         </p:style>
         <p:txBody>
-          <a:bodyPr rtlCol="0" anchor="ctr" wrap="square"/>
+          <a:bodyPr wrap="square" rtlCol="0" anchor="ctr"/>
           <a:lstStyle/>
           <a:p>
             <a:pPr algn="ctr"/>
@@ -7275,7 +7277,7 @@
           </a:fontRef>
         </p:style>
         <p:txBody>
-          <a:bodyPr rtlCol="0" anchor="ctr" wrap="square"/>
+          <a:bodyPr wrap="square" rtlCol="0" anchor="ctr"/>
           <a:lstStyle/>
           <a:p>
             <a:pPr algn="ctr"/>
@@ -7363,7 +7365,7 @@
           </a:fontRef>
         </p:style>
         <p:txBody>
-          <a:bodyPr rtlCol="0" anchor="ctr" wrap="square"/>
+          <a:bodyPr wrap="square" rtlCol="0" anchor="ctr"/>
           <a:lstStyle/>
           <a:p>
             <a:pPr algn="ctr"/>
@@ -7415,7 +7417,7 @@
           </a:fontRef>
         </p:style>
         <p:txBody>
-          <a:bodyPr rtlCol="0" anchor="ctr" wrap="square"/>
+          <a:bodyPr wrap="square" rtlCol="0" anchor="ctr"/>
           <a:lstStyle/>
           <a:p>
             <a:pPr algn="ctr"/>
@@ -7503,7 +7505,7 @@
           </a:fontRef>
         </p:style>
         <p:txBody>
-          <a:bodyPr rtlCol="0" anchor="ctr" wrap="square"/>
+          <a:bodyPr wrap="square" rtlCol="0" anchor="ctr"/>
           <a:lstStyle/>
           <a:p>
             <a:pPr algn="ctr"/>
@@ -7555,7 +7557,7 @@
           </a:fontRef>
         </p:style>
         <p:txBody>
-          <a:bodyPr rtlCol="0" anchor="ctr" wrap="square"/>
+          <a:bodyPr wrap="square" rtlCol="0" anchor="ctr"/>
           <a:lstStyle/>
           <a:p>
             <a:pPr algn="ctr"/>
@@ -7643,7 +7645,7 @@
           </a:fontRef>
         </p:style>
         <p:txBody>
-          <a:bodyPr rtlCol="0" anchor="ctr" wrap="square"/>
+          <a:bodyPr wrap="square" rtlCol="0" anchor="ctr"/>
           <a:lstStyle/>
           <a:p>
             <a:pPr algn="ctr"/>
@@ -7695,7 +7697,7 @@
           </a:fontRef>
         </p:style>
         <p:txBody>
-          <a:bodyPr rtlCol="0" anchor="ctr" wrap="square"/>
+          <a:bodyPr wrap="square" rtlCol="0" anchor="ctr"/>
           <a:lstStyle/>
           <a:p>
             <a:pPr algn="ctr"/>
@@ -7746,6 +7748,12 @@
           </a:p>
           <a:p>
             <a:pPr algn="l"/>
+            <a:endParaRPr sz="1200" b="0">
+              <a:solidFill>
+                <a:srgbClr val="52514E"/>
+              </a:solidFill>
+              <a:latin typeface="Calibri"/>
+            </a:endParaRPr>
           </a:p>
           <a:p>
             <a:pPr algn="l"/>
@@ -7761,6 +7769,12 @@
           </a:p>
           <a:p>
             <a:pPr algn="l"/>
+            <a:endParaRPr sz="1200" b="0">
+              <a:solidFill>
+                <a:srgbClr val="52514E"/>
+              </a:solidFill>
+              <a:latin typeface="Calibri"/>
+            </a:endParaRPr>
           </a:p>
           <a:p>
             <a:pPr algn="l"/>
@@ -7785,7 +7799,7 @@
 </file>
 
 <file path=ppt/slides/slide7.xml><?xml version="1.0" encoding="utf-8"?>
-<p:sld xmlns:a="http://schemas.openxmlformats.org/drawingml/2006/main" xmlns:p="http://schemas.openxmlformats.org/presentationml/2006/main" xmlns:r="http://schemas.openxmlformats.org/officeDocument/2006/relationships">
+<p:sld xmlns:a="http://schemas.openxmlformats.org/drawingml/2006/main" xmlns:r="http://schemas.openxmlformats.org/officeDocument/2006/relationships" xmlns:p="http://schemas.openxmlformats.org/presentationml/2006/main">
   <p:cSld>
     <p:spTree>
       <p:nvGrpSpPr>
@@ -7793,7 +7807,14 @@
         <p:cNvGrpSpPr/>
         <p:nvPr/>
       </p:nvGrpSpPr>
-      <p:grpSpPr/>
+      <p:grpSpPr>
+        <a:xfrm>
+          <a:off x="0" y="0"/>
+          <a:ext cx="0" cy="0"/>
+          <a:chOff x="0" y="0"/>
+          <a:chExt cx="0" cy="0"/>
+        </a:xfrm>
+      </p:grpSpPr>
       <p:sp>
         <p:nvSpPr>
           <p:cNvPr id="2" name="TextBox 1"/>
@@ -7970,7 +7991,7 @@
           </a:fontRef>
         </p:style>
         <p:txBody>
-          <a:bodyPr rtlCol="0" anchor="ctr" wrap="square"/>
+          <a:bodyPr wrap="square" rtlCol="0" anchor="ctr"/>
           <a:lstStyle/>
           <a:p>
             <a:pPr algn="ctr"/>
@@ -8046,7 +8067,7 @@
           </a:fontRef>
         </p:style>
         <p:txBody>
-          <a:bodyPr rtlCol="0" anchor="ctr" wrap="square"/>
+          <a:bodyPr wrap="square" rtlCol="0" anchor="ctr"/>
           <a:lstStyle/>
           <a:p>
             <a:pPr algn="ctr"/>
@@ -8122,7 +8143,7 @@
           </a:fontRef>
         </p:style>
         <p:txBody>
-          <a:bodyPr rtlCol="0" anchor="ctr" wrap="square"/>
+          <a:bodyPr wrap="square" rtlCol="0" anchor="ctr"/>
           <a:lstStyle/>
           <a:p>
             <a:pPr algn="ctr"/>
@@ -8198,7 +8219,7 @@
           </a:fontRef>
         </p:style>
         <p:txBody>
-          <a:bodyPr rtlCol="0" anchor="ctr" wrap="square"/>
+          <a:bodyPr wrap="square" rtlCol="0" anchor="ctr"/>
           <a:lstStyle/>
           <a:p>
             <a:pPr algn="ctr"/>
@@ -8391,7 +8412,7 @@
 </file>
 
 <file path=ppt/slides/slide8.xml><?xml version="1.0" encoding="utf-8"?>
-<p:sld xmlns:a="http://schemas.openxmlformats.org/drawingml/2006/main" xmlns:p="http://schemas.openxmlformats.org/presentationml/2006/main" xmlns:r="http://schemas.openxmlformats.org/officeDocument/2006/relationships">
+<p:sld xmlns:a="http://schemas.openxmlformats.org/drawingml/2006/main" xmlns:r="http://schemas.openxmlformats.org/officeDocument/2006/relationships" xmlns:p="http://schemas.openxmlformats.org/presentationml/2006/main">
   <p:cSld>
     <p:spTree>
       <p:nvGrpSpPr>
@@ -8399,7 +8420,14 @@
         <p:cNvGrpSpPr/>
         <p:nvPr/>
       </p:nvGrpSpPr>
-      <p:grpSpPr/>
+      <p:grpSpPr>
+        <a:xfrm>
+          <a:off x="0" y="0"/>
+          <a:ext cx="0" cy="0"/>
+          <a:chOff x="0" y="0"/>
+          <a:chExt cx="0" cy="0"/>
+        </a:xfrm>
+      </p:grpSpPr>
       <p:sp>
         <p:nvSpPr>
           <p:cNvPr id="2" name="TextBox 1"/>
@@ -8443,7 +8471,7 @@
         </p:nvSpPr>
         <p:spPr>
           <a:xfrm>
-            <a:off x="548640" y="914400"/>
+            <a:off x="485578" y="1111469"/>
             <a:ext cx="10972800" cy="457200"/>
           </a:xfrm>
           <a:prstGeom prst="rect">
@@ -8576,7 +8604,7 @@
           </a:fontRef>
         </p:style>
         <p:txBody>
-          <a:bodyPr rtlCol="0" anchor="ctr" wrap="square"/>
+          <a:bodyPr wrap="square" rtlCol="0" anchor="ctr"/>
           <a:lstStyle/>
           <a:p>
             <a:pPr algn="ctr"/>
@@ -8735,7 +8763,7 @@
           </a:fontRef>
         </p:style>
         <p:txBody>
-          <a:bodyPr rtlCol="0" anchor="ctr" wrap="square"/>
+          <a:bodyPr wrap="square" rtlCol="0" anchor="ctr"/>
           <a:lstStyle/>
           <a:p>
             <a:pPr algn="ctr"/>
@@ -8870,7 +8898,7 @@
           </a:fontRef>
         </p:style>
         <p:txBody>
-          <a:bodyPr rtlCol="0" anchor="ctr" wrap="square"/>
+          <a:bodyPr wrap="square" rtlCol="0" anchor="ctr"/>
           <a:lstStyle/>
           <a:p>
             <a:pPr algn="ctr"/>

</xml_diff>